<commit_message>
Apply meeting fixes: authors, figure order, Figure 1, time series wording
- Drop Yanjun Zhao and Jingrui He from AuthorNames; remove orphaned UIUC affiliation and renumber
- Remove the setcounter override so Figures 2 and 3 follow page order
- Figure 1: replace ModernTSF/TimeSeriesGym with concept tags, unify heading and label sizes, white background
- Use 'Time Series' in Figures 1, 4, 8 and the contribution timeline
- Intro names resource types instead of single tools; ModernTSF footnote moves to its first use
- Section 2: scope of inclusion and layer assignment rules (Table 2)

Co-Authored-By: Claude Opus 5.5 <noreply@anthropic.com>
</commit_message>
<xml_diff>
--- a/artifacts/editorial_accent_20261022/pptx/Figure08_Accent.pptx
+++ b/artifacts/editorial_accent_20261022/pptx/Figure08_Accent.pptx
@@ -1252,7 +1252,7 @@
                     <a:ea typeface="Times New Roman"/>
                     <a:cs typeface="Times New Roman"/>
                   </a:rPr>
-                  <a:t>Task-Specific Time-Series Harness</a:t>
+                  <a:t>Task-Specific Time Series Harness</a:t>
                 </a:r>
                 <a:endParaRPr sz="2640">
                   <a:latin typeface="Comic Sans MS"/>
@@ -4388,6 +4388,10 @@
                 </a:solidFill>
               </a:ln>
             </p:spPr>
+            <p:txBody xmlns:a="http://schemas.openxmlformats.org/drawingml/2006/main">
+              <a:bodyPr/>
+              <a:p/>
+            </p:txBody>
           </p:sp>
           <p:sp>
             <p:nvSpPr>
@@ -4446,6 +4450,10 @@
                 </a:solidFill>
               </a:ln>
             </p:spPr>
+            <p:txBody xmlns:a="http://schemas.openxmlformats.org/drawingml/2006/main">
+              <a:bodyPr/>
+              <a:p/>
+            </p:txBody>
           </p:sp>
           <p:sp>
             <p:nvSpPr>
@@ -4504,6 +4512,10 @@
                 </a:solidFill>
               </a:ln>
             </p:spPr>
+            <p:txBody xmlns:a="http://schemas.openxmlformats.org/drawingml/2006/main">
+              <a:bodyPr/>
+              <a:p/>
+            </p:txBody>
           </p:sp>
           <p:sp>
             <p:nvSpPr>
@@ -4544,6 +4556,10 @@
                 </a:solidFill>
               </a:ln>
             </p:spPr>
+            <p:txBody xmlns:a="http://schemas.openxmlformats.org/drawingml/2006/main">
+              <a:bodyPr/>
+              <a:p/>
+            </p:txBody>
           </p:sp>
           <p:sp>
             <p:nvSpPr>
@@ -4584,6 +4600,10 @@
                 </a:solidFill>
               </a:ln>
             </p:spPr>
+            <p:txBody xmlns:a="http://schemas.openxmlformats.org/drawingml/2006/main">
+              <a:bodyPr/>
+              <a:p/>
+            </p:txBody>
           </p:sp>
           <p:sp>
             <p:nvSpPr>
@@ -4624,6 +4644,10 @@
                 </a:solidFill>
               </a:ln>
             </p:spPr>
+            <p:txBody xmlns:a="http://schemas.openxmlformats.org/drawingml/2006/main">
+              <a:bodyPr/>
+              <a:p/>
+            </p:txBody>
           </p:sp>
           <p:sp>
             <p:nvSpPr>
@@ -4664,6 +4688,10 @@
                 </a:solidFill>
               </a:ln>
             </p:spPr>
+            <p:txBody xmlns:a="http://schemas.openxmlformats.org/drawingml/2006/main">
+              <a:bodyPr/>
+              <a:p/>
+            </p:txBody>
           </p:sp>
           <p:sp>
             <p:nvSpPr>
@@ -4704,6 +4732,10 @@
                 </a:solidFill>
               </a:ln>
             </p:spPr>
+            <p:txBody xmlns:a="http://schemas.openxmlformats.org/drawingml/2006/main">
+              <a:bodyPr/>
+              <a:p/>
+            </p:txBody>
           </p:sp>
           <p:sp>
             <p:nvSpPr>
@@ -4744,6 +4776,10 @@
                 </a:solidFill>
               </a:ln>
             </p:spPr>
+            <p:txBody xmlns:a="http://schemas.openxmlformats.org/drawingml/2006/main">
+              <a:bodyPr/>
+              <a:p/>
+            </p:txBody>
           </p:sp>
           <p:sp>
             <p:nvSpPr>
@@ -4784,6 +4820,10 @@
                 </a:solidFill>
               </a:ln>
             </p:spPr>
+            <p:txBody xmlns:a="http://schemas.openxmlformats.org/drawingml/2006/main">
+              <a:bodyPr/>
+              <a:p/>
+            </p:txBody>
           </p:sp>
           <p:sp>
             <p:nvSpPr>
@@ -4824,6 +4864,10 @@
                 </a:solidFill>
               </a:ln>
             </p:spPr>
+            <p:txBody xmlns:a="http://schemas.openxmlformats.org/drawingml/2006/main">
+              <a:bodyPr/>
+              <a:p/>
+            </p:txBody>
           </p:sp>
           <p:sp>
             <p:nvSpPr>
@@ -4864,6 +4908,10 @@
                 </a:solidFill>
               </a:ln>
             </p:spPr>
+            <p:txBody xmlns:a="http://schemas.openxmlformats.org/drawingml/2006/main">
+              <a:bodyPr/>
+              <a:p/>
+            </p:txBody>
           </p:sp>
           <p:sp>
             <p:nvSpPr>
@@ -4912,6 +4960,10 @@
                 </a:solidFill>
               </a:ln>
             </p:spPr>
+            <p:txBody xmlns:a="http://schemas.openxmlformats.org/drawingml/2006/main">
+              <a:bodyPr/>
+              <a:p/>
+            </p:txBody>
           </p:sp>
           <p:sp>
             <p:nvSpPr>
@@ -4952,6 +5004,10 @@
                 </a:solidFill>
               </a:ln>
             </p:spPr>
+            <p:txBody xmlns:a="http://schemas.openxmlformats.org/drawingml/2006/main">
+              <a:bodyPr/>
+              <a:p/>
+            </p:txBody>
           </p:sp>
           <p:sp>
             <p:nvSpPr>
@@ -4992,6 +5048,10 @@
                 </a:solidFill>
               </a:ln>
             </p:spPr>
+            <p:txBody xmlns:a="http://schemas.openxmlformats.org/drawingml/2006/main">
+              <a:bodyPr/>
+              <a:p/>
+            </p:txBody>
           </p:sp>
           <p:sp>
             <p:nvSpPr>
@@ -5032,6 +5092,10 @@
                 </a:solidFill>
               </a:ln>
             </p:spPr>
+            <p:txBody xmlns:a="http://schemas.openxmlformats.org/drawingml/2006/main">
+              <a:bodyPr/>
+              <a:p/>
+            </p:txBody>
           </p:sp>
           <p:sp>
             <p:nvSpPr>
@@ -5110,6 +5174,10 @@
                 </a:solidFill>
               </a:ln>
             </p:spPr>
+            <p:txBody xmlns:a="http://schemas.openxmlformats.org/drawingml/2006/main">
+              <a:bodyPr/>
+              <a:p/>
+            </p:txBody>
           </p:sp>
           <p:sp>
             <p:nvSpPr>
@@ -5158,6 +5226,10 @@
                 </a:solidFill>
               </a:ln>
             </p:spPr>
+            <p:txBody xmlns:a="http://schemas.openxmlformats.org/drawingml/2006/main">
+              <a:bodyPr/>
+              <a:p/>
+            </p:txBody>
           </p:sp>
           <p:sp>
             <p:nvSpPr>
@@ -5198,6 +5270,10 @@
                 </a:solidFill>
               </a:ln>
             </p:spPr>
+            <p:txBody xmlns:a="http://schemas.openxmlformats.org/drawingml/2006/main">
+              <a:bodyPr/>
+              <a:p/>
+            </p:txBody>
           </p:sp>
           <p:sp>
             <p:nvSpPr>
@@ -5238,6 +5314,10 @@
                 </a:solidFill>
               </a:ln>
             </p:spPr>
+            <p:txBody xmlns:a="http://schemas.openxmlformats.org/drawingml/2006/main">
+              <a:bodyPr/>
+              <a:p/>
+            </p:txBody>
           </p:sp>
           <p:sp>
             <p:nvSpPr>
@@ -5278,6 +5358,10 @@
                 </a:solidFill>
               </a:ln>
             </p:spPr>
+            <p:txBody xmlns:a="http://schemas.openxmlformats.org/drawingml/2006/main">
+              <a:bodyPr/>
+              <a:p/>
+            </p:txBody>
           </p:sp>
         </p:grpSp>
         <p:grpSp>
@@ -8383,6 +8467,10 @@
                 </a:solidFill>
               </a:ln>
             </p:spPr>
+            <p:txBody xmlns:a="http://schemas.openxmlformats.org/drawingml/2006/main">
+              <a:bodyPr/>
+              <a:p/>
+            </p:txBody>
           </p:sp>
           <p:sp>
             <p:nvSpPr>
@@ -8423,6 +8511,10 @@
                 </a:solidFill>
               </a:ln>
             </p:spPr>
+            <p:txBody xmlns:a="http://schemas.openxmlformats.org/drawingml/2006/main">
+              <a:bodyPr/>
+              <a:p/>
+            </p:txBody>
           </p:sp>
           <p:sp>
             <p:nvSpPr>
@@ -8463,6 +8555,10 @@
                 </a:solidFill>
               </a:ln>
             </p:spPr>
+            <p:txBody xmlns:a="http://schemas.openxmlformats.org/drawingml/2006/main">
+              <a:bodyPr/>
+              <a:p/>
+            </p:txBody>
           </p:sp>
           <p:sp>
             <p:nvSpPr>
@@ -8503,6 +8599,10 @@
                 </a:solidFill>
               </a:ln>
             </p:spPr>
+            <p:txBody xmlns:a="http://schemas.openxmlformats.org/drawingml/2006/main">
+              <a:bodyPr/>
+              <a:p/>
+            </p:txBody>
           </p:sp>
           <p:sp>
             <p:nvSpPr>
@@ -8543,6 +8643,10 @@
                 </a:solidFill>
               </a:ln>
             </p:spPr>
+            <p:txBody xmlns:a="http://schemas.openxmlformats.org/drawingml/2006/main">
+              <a:bodyPr/>
+              <a:p/>
+            </p:txBody>
           </p:sp>
           <p:sp>
             <p:nvSpPr>
@@ -8583,6 +8687,10 @@
                 </a:solidFill>
               </a:ln>
             </p:spPr>
+            <p:txBody xmlns:a="http://schemas.openxmlformats.org/drawingml/2006/main">
+              <a:bodyPr/>
+              <a:p/>
+            </p:txBody>
           </p:sp>
           <p:sp>
             <p:nvSpPr>
@@ -8623,6 +8731,10 @@
                 </a:solidFill>
               </a:ln>
             </p:spPr>
+            <p:txBody xmlns:a="http://schemas.openxmlformats.org/drawingml/2006/main">
+              <a:bodyPr/>
+              <a:p/>
+            </p:txBody>
           </p:sp>
           <p:sp>
             <p:nvSpPr>
@@ -8663,6 +8775,10 @@
                 </a:solidFill>
               </a:ln>
             </p:spPr>
+            <p:txBody xmlns:a="http://schemas.openxmlformats.org/drawingml/2006/main">
+              <a:bodyPr/>
+              <a:p/>
+            </p:txBody>
           </p:sp>
           <p:sp>
             <p:nvSpPr>
@@ -8703,6 +8819,10 @@
                 </a:solidFill>
               </a:ln>
             </p:spPr>
+            <p:txBody xmlns:a="http://schemas.openxmlformats.org/drawingml/2006/main">
+              <a:bodyPr/>
+              <a:p/>
+            </p:txBody>
           </p:sp>
           <p:sp>
             <p:nvSpPr>
@@ -8806,6 +8926,10 @@
                 </a:solidFill>
               </a:ln>
             </p:spPr>
+            <p:txBody xmlns:a="http://schemas.openxmlformats.org/drawingml/2006/main">
+              <a:bodyPr/>
+              <a:p/>
+            </p:txBody>
           </p:sp>
           <p:sp>
             <p:nvSpPr>
@@ -8889,6 +9013,10 @@
                 </a:solidFill>
               </a:ln>
             </p:spPr>
+            <p:txBody xmlns:a="http://schemas.openxmlformats.org/drawingml/2006/main">
+              <a:bodyPr/>
+              <a:p/>
+            </p:txBody>
           </p:sp>
           <p:sp>
             <p:nvSpPr>
@@ -8963,6 +9091,10 @@
                 </a:solidFill>
               </a:ln>
             </p:spPr>
+            <p:txBody xmlns:a="http://schemas.openxmlformats.org/drawingml/2006/main">
+              <a:bodyPr/>
+              <a:p/>
+            </p:txBody>
           </p:sp>
           <p:sp>
             <p:nvSpPr>
@@ -9006,6 +9138,10 @@
                 </a:solidFill>
               </a:ln>
             </p:spPr>
+            <p:txBody xmlns:a="http://schemas.openxmlformats.org/drawingml/2006/main">
+              <a:bodyPr/>
+              <a:p/>
+            </p:txBody>
           </p:sp>
           <p:sp>
             <p:nvSpPr>
@@ -9036,6 +9172,10 @@
                 </a:solidFill>
               </a:ln>
             </p:spPr>
+            <p:txBody xmlns:a="http://schemas.openxmlformats.org/drawingml/2006/main">
+              <a:bodyPr/>
+              <a:p/>
+            </p:txBody>
           </p:sp>
           <p:sp>
             <p:nvSpPr>
@@ -9076,6 +9216,10 @@
                 </a:solidFill>
               </a:ln>
             </p:spPr>
+            <p:txBody xmlns:a="http://schemas.openxmlformats.org/drawingml/2006/main">
+              <a:bodyPr/>
+              <a:p/>
+            </p:txBody>
           </p:sp>
         </p:grpSp>
         <p:grpSp>
@@ -11976,6 +12120,10 @@
                 </a:solidFill>
               </a:ln>
             </p:spPr>
+            <p:txBody xmlns:a="http://schemas.openxmlformats.org/drawingml/2006/main">
+              <a:bodyPr/>
+              <a:p/>
+            </p:txBody>
           </p:sp>
           <p:sp>
             <p:nvSpPr>
@@ -12024,6 +12172,10 @@
                 </a:solidFill>
               </a:ln>
             </p:spPr>
+            <p:txBody xmlns:a="http://schemas.openxmlformats.org/drawingml/2006/main">
+              <a:bodyPr/>
+              <a:p/>
+            </p:txBody>
           </p:sp>
           <p:sp>
             <p:nvSpPr>
@@ -12072,6 +12224,10 @@
                 </a:solidFill>
               </a:ln>
             </p:spPr>
+            <p:txBody xmlns:a="http://schemas.openxmlformats.org/drawingml/2006/main">
+              <a:bodyPr/>
+              <a:p/>
+            </p:txBody>
           </p:sp>
           <p:sp>
             <p:nvSpPr>
@@ -12120,6 +12276,10 @@
                 </a:solidFill>
               </a:ln>
             </p:spPr>
+            <p:txBody xmlns:a="http://schemas.openxmlformats.org/drawingml/2006/main">
+              <a:bodyPr/>
+              <a:p/>
+            </p:txBody>
           </p:sp>
           <p:sp>
             <p:nvSpPr>
@@ -12150,6 +12310,10 @@
                 </a:solidFill>
               </a:ln>
             </p:spPr>
+            <p:txBody xmlns:a="http://schemas.openxmlformats.org/drawingml/2006/main">
+              <a:bodyPr/>
+              <a:p/>
+            </p:txBody>
           </p:sp>
           <p:sp>
             <p:nvSpPr>
@@ -12190,6 +12354,10 @@
                 </a:solidFill>
               </a:ln>
             </p:spPr>
+            <p:txBody xmlns:a="http://schemas.openxmlformats.org/drawingml/2006/main">
+              <a:bodyPr/>
+              <a:p/>
+            </p:txBody>
           </p:sp>
           <p:sp>
             <p:nvSpPr>
@@ -12230,6 +12398,10 @@
                 </a:solidFill>
               </a:ln>
             </p:spPr>
+            <p:txBody xmlns:a="http://schemas.openxmlformats.org/drawingml/2006/main">
+              <a:bodyPr/>
+              <a:p/>
+            </p:txBody>
           </p:sp>
           <p:sp>
             <p:nvSpPr>
@@ -12270,6 +12442,10 @@
                 </a:solidFill>
               </a:ln>
             </p:spPr>
+            <p:txBody xmlns:a="http://schemas.openxmlformats.org/drawingml/2006/main">
+              <a:bodyPr/>
+              <a:p/>
+            </p:txBody>
           </p:sp>
           <p:sp>
             <p:nvSpPr>
@@ -12310,6 +12486,10 @@
                 </a:solidFill>
               </a:ln>
             </p:spPr>
+            <p:txBody xmlns:a="http://schemas.openxmlformats.org/drawingml/2006/main">
+              <a:bodyPr/>
+              <a:p/>
+            </p:txBody>
           </p:sp>
           <p:sp>
             <p:nvSpPr>
@@ -12350,6 +12530,10 @@
                 </a:solidFill>
               </a:ln>
             </p:spPr>
+            <p:txBody xmlns:a="http://schemas.openxmlformats.org/drawingml/2006/main">
+              <a:bodyPr/>
+              <a:p/>
+            </p:txBody>
           </p:sp>
           <p:sp>
             <p:nvSpPr>
@@ -12390,6 +12574,10 @@
                 </a:solidFill>
               </a:ln>
             </p:spPr>
+            <p:txBody xmlns:a="http://schemas.openxmlformats.org/drawingml/2006/main">
+              <a:bodyPr/>
+              <a:p/>
+            </p:txBody>
           </p:sp>
           <p:sp>
             <p:nvSpPr>
@@ -12430,6 +12618,10 @@
                 </a:solidFill>
               </a:ln>
             </p:spPr>
+            <p:txBody xmlns:a="http://schemas.openxmlformats.org/drawingml/2006/main">
+              <a:bodyPr/>
+              <a:p/>
+            </p:txBody>
           </p:sp>
           <p:sp>
             <p:nvSpPr>
@@ -12470,6 +12662,10 @@
                 </a:solidFill>
               </a:ln>
             </p:spPr>
+            <p:txBody xmlns:a="http://schemas.openxmlformats.org/drawingml/2006/main">
+              <a:bodyPr/>
+              <a:p/>
+            </p:txBody>
           </p:sp>
           <p:sp>
             <p:nvSpPr>
@@ -12510,6 +12706,10 @@
                 </a:solidFill>
               </a:ln>
             </p:spPr>
+            <p:txBody xmlns:a="http://schemas.openxmlformats.org/drawingml/2006/main">
+              <a:bodyPr/>
+              <a:p/>
+            </p:txBody>
           </p:sp>
           <p:sp>
             <p:nvSpPr>
@@ -12550,6 +12750,10 @@
                 </a:solidFill>
               </a:ln>
             </p:spPr>
+            <p:txBody xmlns:a="http://schemas.openxmlformats.org/drawingml/2006/main">
+              <a:bodyPr/>
+              <a:p/>
+            </p:txBody>
           </p:sp>
           <p:sp>
             <p:nvSpPr>
@@ -12619,6 +12823,10 @@
                 </a:solidFill>
               </a:ln>
             </p:spPr>
+            <p:txBody xmlns:a="http://schemas.openxmlformats.org/drawingml/2006/main">
+              <a:bodyPr/>
+              <a:p/>
+            </p:txBody>
           </p:sp>
           <p:sp>
             <p:nvSpPr>
@@ -12688,6 +12896,10 @@
                 </a:solidFill>
               </a:ln>
             </p:spPr>
+            <p:txBody xmlns:a="http://schemas.openxmlformats.org/drawingml/2006/main">
+              <a:bodyPr/>
+              <a:p/>
+            </p:txBody>
           </p:sp>
           <p:sp>
             <p:nvSpPr>
@@ -12731,6 +12943,10 @@
                 </a:solidFill>
               </a:ln>
             </p:spPr>
+            <p:txBody xmlns:a="http://schemas.openxmlformats.org/drawingml/2006/main">
+              <a:bodyPr/>
+              <a:p/>
+            </p:txBody>
           </p:sp>
           <p:sp>
             <p:nvSpPr>
@@ -12761,6 +12977,10 @@
                 </a:solidFill>
               </a:ln>
             </p:spPr>
+            <p:txBody xmlns:a="http://schemas.openxmlformats.org/drawingml/2006/main">
+              <a:bodyPr/>
+              <a:p/>
+            </p:txBody>
           </p:sp>
           <p:sp>
             <p:nvSpPr>
@@ -12801,6 +13021,10 @@
                 </a:solidFill>
               </a:ln>
             </p:spPr>
+            <p:txBody xmlns:a="http://schemas.openxmlformats.org/drawingml/2006/main">
+              <a:bodyPr/>
+              <a:p/>
+            </p:txBody>
           </p:sp>
         </p:grpSp>
         <p:grpSp>
@@ -15526,6 +15750,10 @@
                 </a:solidFill>
               </a:ln>
             </p:spPr>
+            <p:txBody xmlns:a="http://schemas.openxmlformats.org/drawingml/2006/main">
+              <a:bodyPr/>
+              <a:p/>
+            </p:txBody>
           </p:sp>
           <p:sp>
             <p:nvSpPr>
@@ -15579,6 +15807,10 @@
                 </a:solidFill>
               </a:ln>
             </p:spPr>
+            <p:txBody xmlns:a="http://schemas.openxmlformats.org/drawingml/2006/main">
+              <a:bodyPr/>
+              <a:p/>
+            </p:txBody>
           </p:sp>
           <p:sp>
             <p:nvSpPr>
@@ -15626,6 +15858,10 @@
                 </a:solidFill>
               </a:ln>
             </p:spPr>
+            <p:txBody xmlns:a="http://schemas.openxmlformats.org/drawingml/2006/main">
+              <a:bodyPr/>
+              <a:p/>
+            </p:txBody>
           </p:sp>
           <p:sp>
             <p:nvSpPr>
@@ -15671,6 +15907,10 @@
                 </a:solidFill>
               </a:ln>
             </p:spPr>
+            <p:txBody xmlns:a="http://schemas.openxmlformats.org/drawingml/2006/main">
+              <a:bodyPr/>
+              <a:p/>
+            </p:txBody>
           </p:sp>
           <p:sp>
             <p:nvSpPr>
@@ -15701,6 +15941,10 @@
                 </a:solidFill>
               </a:ln>
             </p:spPr>
+            <p:txBody xmlns:a="http://schemas.openxmlformats.org/drawingml/2006/main">
+              <a:bodyPr/>
+              <a:p/>
+            </p:txBody>
           </p:sp>
           <p:sp>
             <p:nvSpPr>
@@ -15731,6 +15975,10 @@
                 </a:solidFill>
               </a:ln>
             </p:spPr>
+            <p:txBody xmlns:a="http://schemas.openxmlformats.org/drawingml/2006/main">
+              <a:bodyPr/>
+              <a:p/>
+            </p:txBody>
           </p:sp>
           <p:sp>
             <p:nvSpPr>
@@ -15815,6 +16063,10 @@
                 </a:solidFill>
               </a:ln>
             </p:spPr>
+            <p:txBody xmlns:a="http://schemas.openxmlformats.org/drawingml/2006/main">
+              <a:bodyPr/>
+              <a:p/>
+            </p:txBody>
           </p:sp>
           <p:sp>
             <p:nvSpPr>
@@ -15858,6 +16110,10 @@
                 </a:solidFill>
               </a:ln>
             </p:spPr>
+            <p:txBody xmlns:a="http://schemas.openxmlformats.org/drawingml/2006/main">
+              <a:bodyPr/>
+              <a:p/>
+            </p:txBody>
           </p:sp>
         </p:grpSp>
       </p:grpSp>

</xml_diff>